<commit_message>
[20260525] Push prez resto curso v1
</commit_message>
<xml_diff>
--- a/01_PRESENTACIONES/Sesión_15_Validacion_cruzada/archivos_reto/Presentacion_ML_MCCI.pptx
+++ b/01_PRESENTACIONES/Sesión_15_Validacion_cruzada/archivos_reto/Presentacion_ML_MCCI.pptx
@@ -361,7 +361,7 @@
           <a:p>
             <a:fld id="{5BCAD085-E8A6-8845-BD4E-CB4CCA059FC4}" type="datetimeFigureOut">
               <a:rPr lang="en-US" smtClean="0"/>
-              <a:t>5/20/26</a:t>
+              <a:t>5/24/26</a:t>
             </a:fld>
             <a:endParaRPr lang="en-US"/>
           </a:p>
@@ -529,7 +529,7 @@
           <a:p>
             <a:fld id="{5BCAD085-E8A6-8845-BD4E-CB4CCA059FC4}" type="datetimeFigureOut">
               <a:rPr lang="en-US" smtClean="0"/>
-              <a:t>5/20/26</a:t>
+              <a:t>5/24/26</a:t>
             </a:fld>
             <a:endParaRPr lang="en-US"/>
           </a:p>
@@ -707,7 +707,7 @@
           <a:p>
             <a:fld id="{5BCAD085-E8A6-8845-BD4E-CB4CCA059FC4}" type="datetimeFigureOut">
               <a:rPr lang="en-US" smtClean="0"/>
-              <a:t>5/20/26</a:t>
+              <a:t>5/24/26</a:t>
             </a:fld>
             <a:endParaRPr lang="en-US"/>
           </a:p>
@@ -875,7 +875,7 @@
           <a:p>
             <a:fld id="{5BCAD085-E8A6-8845-BD4E-CB4CCA059FC4}" type="datetimeFigureOut">
               <a:rPr lang="en-US" smtClean="0"/>
-              <a:t>5/20/26</a:t>
+              <a:t>5/24/26</a:t>
             </a:fld>
             <a:endParaRPr lang="en-US"/>
           </a:p>
@@ -1120,7 +1120,7 @@
           <a:p>
             <a:fld id="{5BCAD085-E8A6-8845-BD4E-CB4CCA059FC4}" type="datetimeFigureOut">
               <a:rPr lang="en-US" smtClean="0"/>
-              <a:t>5/20/26</a:t>
+              <a:t>5/24/26</a:t>
             </a:fld>
             <a:endParaRPr lang="en-US"/>
           </a:p>
@@ -1405,7 +1405,7 @@
           <a:p>
             <a:fld id="{5BCAD085-E8A6-8845-BD4E-CB4CCA059FC4}" type="datetimeFigureOut">
               <a:rPr lang="en-US" smtClean="0"/>
-              <a:t>5/20/26</a:t>
+              <a:t>5/24/26</a:t>
             </a:fld>
             <a:endParaRPr lang="en-US"/>
           </a:p>
@@ -1824,7 +1824,7 @@
           <a:p>
             <a:fld id="{5BCAD085-E8A6-8845-BD4E-CB4CCA059FC4}" type="datetimeFigureOut">
               <a:rPr lang="en-US" smtClean="0"/>
-              <a:t>5/20/26</a:t>
+              <a:t>5/24/26</a:t>
             </a:fld>
             <a:endParaRPr lang="en-US"/>
           </a:p>
@@ -1941,7 +1941,7 @@
           <a:p>
             <a:fld id="{5BCAD085-E8A6-8845-BD4E-CB4CCA059FC4}" type="datetimeFigureOut">
               <a:rPr lang="en-US" smtClean="0"/>
-              <a:t>5/20/26</a:t>
+              <a:t>5/24/26</a:t>
             </a:fld>
             <a:endParaRPr lang="en-US"/>
           </a:p>
@@ -2036,7 +2036,7 @@
           <a:p>
             <a:fld id="{5BCAD085-E8A6-8845-BD4E-CB4CCA059FC4}" type="datetimeFigureOut">
               <a:rPr lang="en-US" smtClean="0"/>
-              <a:t>5/20/26</a:t>
+              <a:t>5/24/26</a:t>
             </a:fld>
             <a:endParaRPr lang="en-US"/>
           </a:p>
@@ -2311,7 +2311,7 @@
           <a:p>
             <a:fld id="{5BCAD085-E8A6-8845-BD4E-CB4CCA059FC4}" type="datetimeFigureOut">
               <a:rPr lang="en-US" smtClean="0"/>
-              <a:t>5/20/26</a:t>
+              <a:t>5/24/26</a:t>
             </a:fld>
             <a:endParaRPr lang="en-US"/>
           </a:p>
@@ -2563,7 +2563,7 @@
           <a:p>
             <a:fld id="{5BCAD085-E8A6-8845-BD4E-CB4CCA059FC4}" type="datetimeFigureOut">
               <a:rPr lang="en-US" smtClean="0"/>
-              <a:t>5/20/26</a:t>
+              <a:t>5/24/26</a:t>
             </a:fld>
             <a:endParaRPr lang="en-US"/>
           </a:p>
@@ -2774,7 +2774,7 @@
           <a:p>
             <a:fld id="{5BCAD085-E8A6-8845-BD4E-CB4CCA059FC4}" type="datetimeFigureOut">
               <a:rPr lang="en-US" smtClean="0"/>
-              <a:t>5/20/26</a:t>
+              <a:t>5/24/26</a:t>
             </a:fld>
             <a:endParaRPr lang="en-US"/>
           </a:p>
@@ -6797,7 +6797,7 @@
         </p:nvSpPr>
         <p:spPr>
           <a:xfrm>
-            <a:off x="0" y="0"/>
+            <a:off x="0" y="274320"/>
             <a:ext cx="9144000" cy="6858000"/>
           </a:xfrm>
           <a:prstGeom prst="rect">
@@ -6843,7 +6843,7 @@
         <p:spPr>
           <a:xfrm>
             <a:off x="0" y="274320"/>
-            <a:ext cx="5486400" cy="640080"/>
+            <a:ext cx="7113180" cy="640080"/>
           </a:xfrm>
           <a:prstGeom prst="rect">
             <a:avLst/>
@@ -6887,8 +6887,8 @@
         </p:nvSpPr>
         <p:spPr>
           <a:xfrm>
-            <a:off x="0" y="274320"/>
-            <a:ext cx="5486400" cy="640080"/>
+            <a:off x="-1" y="409694"/>
+            <a:ext cx="7113181" cy="369332"/>
           </a:xfrm>
           <a:prstGeom prst="rect">
             <a:avLst/>
@@ -6903,13 +6903,67 @@
           <a:p>
             <a:pPr algn="ctr"/>
             <a:r>
-              <a:rPr sz="2400" b="1" i="0">
+              <a:rPr sz="2400" b="1" i="0" dirty="0">
                 <a:solidFill>
                   <a:srgbClr val="FFFFFF"/>
                 </a:solidFill>
                 <a:latin typeface="Ubuntu"/>
               </a:rPr>
-              <a:t>parsnip: una sintaxis, muchos engines</a:t>
+              <a:t>parsnip: </a:t>
+            </a:r>
+            <a:r>
+              <a:rPr sz="2400" b="1" i="0" dirty="0" err="1">
+                <a:solidFill>
+                  <a:srgbClr val="FFFFFF"/>
+                </a:solidFill>
+                <a:latin typeface="Ubuntu"/>
+              </a:rPr>
+              <a:t>una</a:t>
+            </a:r>
+            <a:r>
+              <a:rPr sz="2400" b="1" i="0" dirty="0">
+                <a:solidFill>
+                  <a:srgbClr val="FFFFFF"/>
+                </a:solidFill>
+                <a:latin typeface="Ubuntu"/>
+              </a:rPr>
+              <a:t> </a:t>
+            </a:r>
+            <a:r>
+              <a:rPr sz="2400" b="1" i="0" dirty="0" err="1">
+                <a:solidFill>
+                  <a:srgbClr val="FFFFFF"/>
+                </a:solidFill>
+                <a:latin typeface="Ubuntu"/>
+              </a:rPr>
+              <a:t>sintaxis</a:t>
+            </a:r>
+            <a:r>
+              <a:rPr sz="2400" b="1" i="0" dirty="0">
+                <a:solidFill>
+                  <a:srgbClr val="FFFFFF"/>
+                </a:solidFill>
+                <a:latin typeface="Ubuntu"/>
+              </a:rPr>
+              <a:t>, </a:t>
+            </a:r>
+            <a:r>
+              <a:rPr sz="2400" b="1" i="0" dirty="0" err="1">
+                <a:solidFill>
+                  <a:srgbClr val="FFFFFF"/>
+                </a:solidFill>
+                <a:latin typeface="Ubuntu"/>
+              </a:rPr>
+              <a:t>muchos</a:t>
+            </a:r>
+            <a:r>
+              <a:rPr sz="2400" b="1" i="0" dirty="0">
+                <a:solidFill>
+                  <a:srgbClr val="FFFFFF"/>
+                </a:solidFill>
+                <a:latin typeface="Ubuntu"/>
+              </a:rPr>
+              <a:t> engines</a:t>
             </a:r>
           </a:p>
         </p:txBody>
@@ -8173,7 +8227,7 @@
         <p:spPr>
           <a:xfrm>
             <a:off x="0" y="274320"/>
-            <a:ext cx="5486400" cy="640080"/>
+            <a:ext cx="7272670" cy="640080"/>
           </a:xfrm>
           <a:prstGeom prst="rect">
             <a:avLst/>
@@ -8217,8 +8271,8 @@
         </p:nvSpPr>
         <p:spPr>
           <a:xfrm>
-            <a:off x="0" y="274320"/>
-            <a:ext cx="5486400" cy="640080"/>
+            <a:off x="-1" y="409694"/>
+            <a:ext cx="6836735" cy="369332"/>
           </a:xfrm>
           <a:prstGeom prst="rect">
             <a:avLst/>
@@ -8233,14 +8287,83 @@
           <a:p>
             <a:pPr algn="ctr"/>
             <a:r>
-              <a:rPr sz="2400" b="1" i="0">
+              <a:rPr sz="2400" b="1" i="0" dirty="0">
                 <a:solidFill>
                   <a:srgbClr val="FFFFFF"/>
                 </a:solidFill>
                 <a:latin typeface="Ubuntu"/>
               </a:rPr>
-              <a:t>Workflow: receta + modelo en un solo objeto</a:t>
-            </a:r>
+              <a:t>Workflow: </a:t>
+            </a:r>
+            <a:r>
+              <a:rPr sz="2400" b="1" i="0" dirty="0" err="1">
+                <a:solidFill>
+                  <a:srgbClr val="FFFFFF"/>
+                </a:solidFill>
+                <a:latin typeface="Ubuntu"/>
+              </a:rPr>
+              <a:t>receta</a:t>
+            </a:r>
+            <a:r>
+              <a:rPr sz="2400" b="1" i="0" dirty="0">
+                <a:solidFill>
+                  <a:srgbClr val="FFFFFF"/>
+                </a:solidFill>
+                <a:latin typeface="Ubuntu"/>
+              </a:rPr>
+              <a:t> + </a:t>
+            </a:r>
+            <a:r>
+              <a:rPr sz="2400" b="1" i="0" dirty="0" err="1">
+                <a:solidFill>
+                  <a:srgbClr val="FFFFFF"/>
+                </a:solidFill>
+                <a:latin typeface="Ubuntu"/>
+              </a:rPr>
+              <a:t>modelo</a:t>
+            </a:r>
+            <a:r>
+              <a:rPr sz="2400" b="1" i="0" dirty="0">
+                <a:solidFill>
+                  <a:srgbClr val="FFFFFF"/>
+                </a:solidFill>
+                <a:latin typeface="Ubuntu"/>
+              </a:rPr>
+              <a:t> </a:t>
+            </a:r>
+            <a:r>
+              <a:rPr sz="2400" b="1" i="0" dirty="0" err="1">
+                <a:solidFill>
+                  <a:srgbClr val="FFFFFF"/>
+                </a:solidFill>
+                <a:latin typeface="Ubuntu"/>
+              </a:rPr>
+              <a:t>en</a:t>
+            </a:r>
+            <a:r>
+              <a:rPr sz="2400" b="1" i="0" dirty="0">
+                <a:solidFill>
+                  <a:srgbClr val="FFFFFF"/>
+                </a:solidFill>
+                <a:latin typeface="Ubuntu"/>
+              </a:rPr>
+              <a:t> un solo </a:t>
+            </a:r>
+            <a:r>
+              <a:rPr sz="2400" b="1" i="0" dirty="0" err="1">
+                <a:solidFill>
+                  <a:srgbClr val="FFFFFF"/>
+                </a:solidFill>
+                <a:latin typeface="Ubuntu"/>
+              </a:rPr>
+              <a:t>objeto</a:t>
+            </a:r>
+            <a:endParaRPr sz="2400" b="1" i="0" dirty="0">
+              <a:solidFill>
+                <a:srgbClr val="FFFFFF"/>
+              </a:solidFill>
+              <a:latin typeface="Ubuntu"/>
+            </a:endParaRPr>
           </a:p>
         </p:txBody>
       </p:sp>
@@ -13572,7 +13695,7 @@
         <p:spPr>
           <a:xfrm>
             <a:off x="0" y="274320"/>
-            <a:ext cx="5486400" cy="640080"/>
+            <a:ext cx="7304566" cy="640080"/>
           </a:xfrm>
           <a:prstGeom prst="rect">
             <a:avLst/>
@@ -13616,8 +13739,8 @@
         </p:nvSpPr>
         <p:spPr>
           <a:xfrm>
-            <a:off x="0" y="274320"/>
-            <a:ext cx="5486400" cy="640080"/>
+            <a:off x="-1" y="409694"/>
+            <a:ext cx="7304567" cy="369332"/>
           </a:xfrm>
           <a:prstGeom prst="rect">
             <a:avLst/>
@@ -20425,8 +20548,8 @@
         </p:nvSpPr>
         <p:spPr>
           <a:xfrm>
-            <a:off x="0" y="274320"/>
-            <a:ext cx="5486400" cy="640080"/>
+            <a:off x="-1" y="274320"/>
+            <a:ext cx="7187609" cy="640080"/>
           </a:xfrm>
           <a:prstGeom prst="rect">
             <a:avLst/>
@@ -20470,8 +20593,8 @@
         </p:nvSpPr>
         <p:spPr>
           <a:xfrm>
-            <a:off x="0" y="274320"/>
-            <a:ext cx="5486400" cy="640080"/>
+            <a:off x="0" y="409694"/>
+            <a:ext cx="6400800" cy="369332"/>
           </a:xfrm>
           <a:prstGeom prst="rect">
             <a:avLst/>
@@ -20486,14 +20609,47 @@
           <a:p>
             <a:pPr algn="ctr"/>
             <a:r>
-              <a:rPr sz="2400" b="1" i="0">
+              <a:rPr sz="2400" b="1" i="0" dirty="0">
                 <a:solidFill>
                   <a:srgbClr val="FFFFFF"/>
                 </a:solidFill>
                 <a:latin typeface="Ubuntu"/>
               </a:rPr>
-              <a:t>Trampa #2: Usar el test set para decidir</a:t>
-            </a:r>
+              <a:t>Trampa #2: Usar </a:t>
+            </a:r>
+            <a:r>
+              <a:rPr sz="2400" b="1" i="0" dirty="0" err="1">
+                <a:solidFill>
+                  <a:srgbClr val="FFFFFF"/>
+                </a:solidFill>
+                <a:latin typeface="Ubuntu"/>
+              </a:rPr>
+              <a:t>el</a:t>
+            </a:r>
+            <a:r>
+              <a:rPr sz="2400" b="1" i="0" dirty="0">
+                <a:solidFill>
+                  <a:srgbClr val="FFFFFF"/>
+                </a:solidFill>
+                <a:latin typeface="Ubuntu"/>
+              </a:rPr>
+              <a:t> test set para </a:t>
+            </a:r>
+            <a:r>
+              <a:rPr sz="2400" b="1" i="0" dirty="0" err="1">
+                <a:solidFill>
+                  <a:srgbClr val="FFFFFF"/>
+                </a:solidFill>
+                <a:latin typeface="Ubuntu"/>
+              </a:rPr>
+              <a:t>decidir</a:t>
+            </a:r>
+            <a:endParaRPr sz="2400" b="1" i="0" dirty="0">
+              <a:solidFill>
+                <a:srgbClr val="FFFFFF"/>
+              </a:solidFill>
+              <a:latin typeface="Ubuntu"/>
+            </a:endParaRPr>
           </a:p>
         </p:txBody>
       </p:sp>
@@ -28292,7 +28448,7 @@
         </p:nvSpPr>
         <p:spPr>
           <a:xfrm>
-            <a:off x="384048" y="4526280"/>
+            <a:off x="402336" y="4549140"/>
             <a:ext cx="8375904" cy="1691640"/>
           </a:xfrm>
           <a:prstGeom prst="rect">
@@ -28450,7 +28606,7 @@
         <p:spPr>
           <a:xfrm>
             <a:off x="0" y="274320"/>
-            <a:ext cx="5486400" cy="640080"/>
+            <a:ext cx="6967726" cy="640080"/>
           </a:xfrm>
           <a:prstGeom prst="rect">
             <a:avLst/>
@@ -28494,8 +28650,8 @@
         </p:nvSpPr>
         <p:spPr>
           <a:xfrm>
-            <a:off x="0" y="274320"/>
-            <a:ext cx="5486400" cy="640080"/>
+            <a:off x="-1" y="409694"/>
+            <a:ext cx="6967727" cy="369332"/>
           </a:xfrm>
           <a:prstGeom prst="rect">
             <a:avLst/>
@@ -28510,13 +28666,49 @@
           <a:p>
             <a:pPr algn="ctr"/>
             <a:r>
-              <a:rPr sz="2400" b="1" i="0">
+              <a:rPr sz="2400" b="1" i="0" dirty="0">
                 <a:solidFill>
                   <a:srgbClr val="FFFFFF"/>
                 </a:solidFill>
                 <a:latin typeface="Ubuntu"/>
               </a:rPr>
-              <a:t>El pipeline completo de un proyecto de ML</a:t>
+              <a:t>El pipeline </a:t>
+            </a:r>
+            <a:r>
+              <a:rPr sz="2400" b="1" i="0" dirty="0" err="1">
+                <a:solidFill>
+                  <a:srgbClr val="FFFFFF"/>
+                </a:solidFill>
+                <a:latin typeface="Ubuntu"/>
+              </a:rPr>
+              <a:t>completo</a:t>
+            </a:r>
+            <a:r>
+              <a:rPr sz="2400" b="1" i="0" dirty="0">
+                <a:solidFill>
+                  <a:srgbClr val="FFFFFF"/>
+                </a:solidFill>
+                <a:latin typeface="Ubuntu"/>
+              </a:rPr>
+              <a:t> de un </a:t>
+            </a:r>
+            <a:r>
+              <a:rPr sz="2400" b="1" i="0" dirty="0" err="1">
+                <a:solidFill>
+                  <a:srgbClr val="FFFFFF"/>
+                </a:solidFill>
+                <a:latin typeface="Ubuntu"/>
+              </a:rPr>
+              <a:t>proyecto</a:t>
+            </a:r>
+            <a:r>
+              <a:rPr sz="2400" b="1" i="0" dirty="0">
+                <a:solidFill>
+                  <a:srgbClr val="FFFFFF"/>
+                </a:solidFill>
+                <a:latin typeface="Ubuntu"/>
+              </a:rPr>
+              <a:t> de ML</a:t>
             </a:r>
           </a:p>
         </p:txBody>

</xml_diff>